<commit_message>
Railway BD PostGreSQL .....
</commit_message>
<xml_diff>
--- a/01 Classes/Aula 12, 13 RAD Python - Banco de Dados.pptx
+++ b/01 Classes/Aula 12, 13 RAD Python - Banco de Dados.pptx
@@ -1823,7 +1823,7 @@
           <a:p>
             <a:fld id="{48A87A34-81AB-432B-8DAE-1953F412C126}" type="datetimeFigureOut">
               <a:rPr lang="en-US" smtClean="0"/>
-              <a:t>4/27/2026</a:t>
+              <a:t>4/28/2026</a:t>
             </a:fld>
             <a:endParaRPr lang="en-US" dirty="0"/>
           </a:p>
@@ -2034,7 +2034,7 @@
           <a:p>
             <a:fld id="{48A87A34-81AB-432B-8DAE-1953F412C126}" type="datetimeFigureOut">
               <a:rPr lang="en-US" smtClean="0"/>
-              <a:t>4/27/2026</a:t>
+              <a:t>4/28/2026</a:t>
             </a:fld>
             <a:endParaRPr lang="en-US" dirty="0"/>
           </a:p>
@@ -2249,7 +2249,7 @@
           <a:p>
             <a:fld id="{48A87A34-81AB-432B-8DAE-1953F412C126}" type="datetimeFigureOut">
               <a:rPr lang="en-US" smtClean="0"/>
-              <a:t>4/27/2026</a:t>
+              <a:t>4/28/2026</a:t>
             </a:fld>
             <a:endParaRPr lang="en-US" dirty="0"/>
           </a:p>
@@ -2617,7 +2617,7 @@
           <a:p>
             <a:fld id="{48A87A34-81AB-432B-8DAE-1953F412C126}" type="datetimeFigureOut">
               <a:rPr lang="en-US" smtClean="0"/>
-              <a:t>4/27/2026</a:t>
+              <a:t>4/28/2026</a:t>
             </a:fld>
             <a:endParaRPr lang="en-US" dirty="0"/>
           </a:p>
@@ -2896,7 +2896,7 @@
           <a:p>
             <a:fld id="{48A87A34-81AB-432B-8DAE-1953F412C126}" type="datetimeFigureOut">
               <a:rPr lang="en-US" smtClean="0"/>
-              <a:t>4/27/2026</a:t>
+              <a:t>4/28/2026</a:t>
             </a:fld>
             <a:endParaRPr lang="en-US" dirty="0"/>
           </a:p>
@@ -3164,7 +3164,7 @@
           <a:p>
             <a:fld id="{48A87A34-81AB-432B-8DAE-1953F412C126}" type="datetimeFigureOut">
               <a:rPr lang="en-US" smtClean="0"/>
-              <a:t>4/27/2026</a:t>
+              <a:t>4/28/2026</a:t>
             </a:fld>
             <a:endParaRPr lang="en-US" dirty="0"/>
           </a:p>
@@ -3580,7 +3580,7 @@
           <a:p>
             <a:fld id="{48A87A34-81AB-432B-8DAE-1953F412C126}" type="datetimeFigureOut">
               <a:rPr lang="en-US" smtClean="0"/>
-              <a:t>4/27/2026</a:t>
+              <a:t>4/28/2026</a:t>
             </a:fld>
             <a:endParaRPr lang="en-US" dirty="0"/>
           </a:p>
@@ -3729,7 +3729,7 @@
           <a:p>
             <a:fld id="{48A87A34-81AB-432B-8DAE-1953F412C126}" type="datetimeFigureOut">
               <a:rPr lang="en-US" smtClean="0"/>
-              <a:t>4/27/2026</a:t>
+              <a:t>4/28/2026</a:t>
             </a:fld>
             <a:endParaRPr lang="en-US" dirty="0"/>
           </a:p>
@@ -3855,7 +3855,7 @@
           <a:p>
             <a:fld id="{48A87A34-81AB-432B-8DAE-1953F412C126}" type="datetimeFigureOut">
               <a:rPr lang="en-US" smtClean="0"/>
-              <a:t>4/27/2026</a:t>
+              <a:t>4/28/2026</a:t>
             </a:fld>
             <a:endParaRPr lang="en-US" dirty="0"/>
           </a:p>
@@ -4106,7 +4106,7 @@
           <a:p>
             <a:fld id="{48A87A34-81AB-432B-8DAE-1953F412C126}" type="datetimeFigureOut">
               <a:rPr lang="en-US" smtClean="0"/>
-              <a:t>4/27/2026</a:t>
+              <a:t>4/28/2026</a:t>
             </a:fld>
             <a:endParaRPr lang="en-US" dirty="0"/>
           </a:p>
@@ -4552,7 +4552,7 @@
             <a:fld id="{48A87A34-81AB-432B-8DAE-1953F412C126}" type="datetimeFigureOut">
               <a:rPr lang="en-US" smtClean="0"/>
               <a:pPr/>
-              <a:t>4/27/2026</a:t>
+              <a:t>4/28/2026</a:t>
             </a:fld>
             <a:endParaRPr lang="en-US" dirty="0"/>
           </a:p>
@@ -4887,7 +4887,7 @@
             <a:fld id="{48A87A34-81AB-432B-8DAE-1953F412C126}" type="datetimeFigureOut">
               <a:rPr lang="en-US" smtClean="0"/>
               <a:pPr/>
-              <a:t>4/27/2026</a:t>
+              <a:t>4/28/2026</a:t>
             </a:fld>
             <a:endParaRPr lang="en-US" dirty="0"/>
           </a:p>
@@ -6775,7 +6775,7 @@
                 <a:latin typeface="Times New Roman" panose="02020603050405020304" pitchFamily="18" charset="0"/>
                 <a:cs typeface="Times New Roman" panose="02020603050405020304" pitchFamily="18" charset="0"/>
               </a:rPr>
-              <a:t>cur.close</a:t>
+              <a:t>cursor.close</a:t>
             </a:r>
             <a:r>
               <a:rPr lang="pt-BR" sz="1800" dirty="0">
@@ -7109,39 +7109,82 @@
               <a:buNone/>
             </a:pPr>
             <a:r>
+              <a:rPr lang="pt-BR" sz="1600" dirty="0">
+                <a:latin typeface="Times New Roman" panose="02020603050405020304" pitchFamily="18" charset="0"/>
+                <a:cs typeface="Times New Roman" panose="02020603050405020304" pitchFamily="18" charset="0"/>
+              </a:rPr>
+              <a:t>cursor = </a:t>
+            </a:r>
+            <a:r>
+              <a:rPr lang="pt-BR" sz="1600" b="1" dirty="0" err="1">
+                <a:latin typeface="Times New Roman" panose="02020603050405020304" pitchFamily="18" charset="0"/>
+                <a:cs typeface="Times New Roman" panose="02020603050405020304" pitchFamily="18" charset="0"/>
+              </a:rPr>
+              <a:t>conn</a:t>
+            </a:r>
+            <a:r>
               <a:rPr lang="pt-BR" sz="1600" dirty="0" err="1">
                 <a:latin typeface="Times New Roman" panose="02020603050405020304" pitchFamily="18" charset="0"/>
                 <a:cs typeface="Times New Roman" panose="02020603050405020304" pitchFamily="18" charset="0"/>
               </a:rPr>
-              <a:t>cur</a:t>
+              <a:t>.cursor</a:t>
             </a:r>
             <a:r>
               <a:rPr lang="pt-BR" sz="1600" dirty="0">
                 <a:latin typeface="Times New Roman" panose="02020603050405020304" pitchFamily="18" charset="0"/>
                 <a:cs typeface="Times New Roman" panose="02020603050405020304" pitchFamily="18" charset="0"/>
               </a:rPr>
-              <a:t> = </a:t>
-            </a:r>
-            <a:r>
-              <a:rPr lang="pt-BR" sz="1600" b="1" dirty="0" err="1">
-                <a:latin typeface="Times New Roman" panose="02020603050405020304" pitchFamily="18" charset="0"/>
-                <a:cs typeface="Times New Roman" panose="02020603050405020304" pitchFamily="18" charset="0"/>
-              </a:rPr>
-              <a:t>conn</a:t>
-            </a:r>
+              <a:t>()</a:t>
+            </a:r>
+          </a:p>
+          <a:p>
+            <a:pPr marL="0" indent="0" algn="just">
+              <a:buNone/>
+            </a:pPr>
             <a:r>
               <a:rPr lang="pt-BR" sz="1600" dirty="0" err="1">
                 <a:latin typeface="Times New Roman" panose="02020603050405020304" pitchFamily="18" charset="0"/>
                 <a:cs typeface="Times New Roman" panose="02020603050405020304" pitchFamily="18" charset="0"/>
               </a:rPr>
-              <a:t>.cursor</a:t>
+              <a:t>cursor.execute</a:t>
             </a:r>
             <a:r>
               <a:rPr lang="pt-BR" sz="1600" dirty="0">
                 <a:latin typeface="Times New Roman" panose="02020603050405020304" pitchFamily="18" charset="0"/>
                 <a:cs typeface="Times New Roman" panose="02020603050405020304" pitchFamily="18" charset="0"/>
               </a:rPr>
-              <a:t>()</a:t>
+              <a:t>("</a:t>
+            </a:r>
+            <a:r>
+              <a:rPr lang="pt-BR" sz="1600" b="1" dirty="0">
+                <a:solidFill>
+                  <a:srgbClr val="FF0000"/>
+                </a:solidFill>
+                <a:latin typeface="Times New Roman" panose="02020603050405020304" pitchFamily="18" charset="0"/>
+                <a:cs typeface="Times New Roman" panose="02020603050405020304" pitchFamily="18" charset="0"/>
+              </a:rPr>
+              <a:t>SELECT</a:t>
+            </a:r>
+            <a:r>
+              <a:rPr lang="pt-BR" sz="1600" dirty="0">
+                <a:latin typeface="Times New Roman" panose="02020603050405020304" pitchFamily="18" charset="0"/>
+                <a:cs typeface="Times New Roman" panose="02020603050405020304" pitchFamily="18" charset="0"/>
+              </a:rPr>
+              <a:t> </a:t>
+            </a:r>
+            <a:r>
+              <a:rPr lang="pt-BR" sz="1600" dirty="0" err="1">
+                <a:latin typeface="Times New Roman" panose="02020603050405020304" pitchFamily="18" charset="0"/>
+                <a:cs typeface="Times New Roman" panose="02020603050405020304" pitchFamily="18" charset="0"/>
+              </a:rPr>
+              <a:t>version</a:t>
+            </a:r>
+            <a:r>
+              <a:rPr lang="pt-BR" sz="1600" dirty="0">
+                <a:latin typeface="Times New Roman" panose="02020603050405020304" pitchFamily="18" charset="0"/>
+                <a:cs typeface="Times New Roman" panose="02020603050405020304" pitchFamily="18" charset="0"/>
+              </a:rPr>
+              <a:t>();")</a:t>
             </a:r>
           </a:p>
           <a:p>
@@ -7149,70 +7192,37 @@
               <a:buNone/>
             </a:pPr>
             <a:r>
+              <a:rPr lang="pt-BR" sz="1600" dirty="0">
+                <a:latin typeface="Times New Roman" panose="02020603050405020304" pitchFamily="18" charset="0"/>
+                <a:cs typeface="Times New Roman" panose="02020603050405020304" pitchFamily="18" charset="0"/>
+              </a:rPr>
+              <a:t>print(</a:t>
+            </a:r>
+            <a:r>
               <a:rPr lang="pt-BR" sz="1600" dirty="0" err="1">
                 <a:latin typeface="Times New Roman" panose="02020603050405020304" pitchFamily="18" charset="0"/>
                 <a:cs typeface="Times New Roman" panose="02020603050405020304" pitchFamily="18" charset="0"/>
               </a:rPr>
-              <a:t>cur.execute</a:t>
+              <a:t>cursor.fetchone</a:t>
             </a:r>
             <a:r>
               <a:rPr lang="pt-BR" sz="1600" dirty="0">
                 <a:latin typeface="Times New Roman" panose="02020603050405020304" pitchFamily="18" charset="0"/>
                 <a:cs typeface="Times New Roman" panose="02020603050405020304" pitchFamily="18" charset="0"/>
               </a:rPr>
-              <a:t>("SELECT </a:t>
-            </a:r>
+              <a:t>())</a:t>
+            </a:r>
+          </a:p>
+          <a:p>
+            <a:pPr marL="0" indent="0" algn="just">
+              <a:buNone/>
+            </a:pPr>
             <a:r>
               <a:rPr lang="pt-BR" sz="1600" dirty="0" err="1">
                 <a:latin typeface="Times New Roman" panose="02020603050405020304" pitchFamily="18" charset="0"/>
                 <a:cs typeface="Times New Roman" panose="02020603050405020304" pitchFamily="18" charset="0"/>
               </a:rPr>
-              <a:t>version</a:t>
-            </a:r>
-            <a:r>
-              <a:rPr lang="pt-BR" sz="1600" dirty="0">
-                <a:latin typeface="Times New Roman" panose="02020603050405020304" pitchFamily="18" charset="0"/>
-                <a:cs typeface="Times New Roman" panose="02020603050405020304" pitchFamily="18" charset="0"/>
-              </a:rPr>
-              <a:t>();")</a:t>
-            </a:r>
-          </a:p>
-          <a:p>
-            <a:pPr marL="0" indent="0" algn="just">
-              <a:buNone/>
-            </a:pPr>
-            <a:r>
-              <a:rPr lang="pt-BR" sz="1600" dirty="0">
-                <a:latin typeface="Times New Roman" panose="02020603050405020304" pitchFamily="18" charset="0"/>
-                <a:cs typeface="Times New Roman" panose="02020603050405020304" pitchFamily="18" charset="0"/>
-              </a:rPr>
-              <a:t>print(</a:t>
-            </a:r>
-            <a:r>
-              <a:rPr lang="pt-BR" sz="1600" dirty="0" err="1">
-                <a:latin typeface="Times New Roman" panose="02020603050405020304" pitchFamily="18" charset="0"/>
-                <a:cs typeface="Times New Roman" panose="02020603050405020304" pitchFamily="18" charset="0"/>
-              </a:rPr>
-              <a:t>cur.fetchone</a:t>
-            </a:r>
-            <a:r>
-              <a:rPr lang="pt-BR" sz="1600" dirty="0">
-                <a:latin typeface="Times New Roman" panose="02020603050405020304" pitchFamily="18" charset="0"/>
-                <a:cs typeface="Times New Roman" panose="02020603050405020304" pitchFamily="18" charset="0"/>
-              </a:rPr>
-              <a:t>())</a:t>
-            </a:r>
-          </a:p>
-          <a:p>
-            <a:pPr marL="0" indent="0" algn="just">
-              <a:buNone/>
-            </a:pPr>
-            <a:r>
-              <a:rPr lang="pt-BR" sz="1600" dirty="0" err="1">
-                <a:latin typeface="Times New Roman" panose="02020603050405020304" pitchFamily="18" charset="0"/>
-                <a:cs typeface="Times New Roman" panose="02020603050405020304" pitchFamily="18" charset="0"/>
-              </a:rPr>
-              <a:t>cur.close</a:t>
+              <a:t>cursor.close</a:t>
             </a:r>
             <a:r>
               <a:rPr lang="pt-BR" sz="1600" dirty="0">
@@ -7449,39 +7459,181 @@
               <a:buNone/>
             </a:pPr>
             <a:r>
+              <a:rPr lang="pt-BR" sz="1600" dirty="0">
+                <a:latin typeface="Times New Roman" panose="02020603050405020304" pitchFamily="18" charset="0"/>
+                <a:cs typeface="Times New Roman" panose="02020603050405020304" pitchFamily="18" charset="0"/>
+              </a:rPr>
+              <a:t>cursor = </a:t>
+            </a:r>
+            <a:r>
+              <a:rPr lang="pt-BR" sz="1600" b="1" dirty="0" err="1">
+                <a:latin typeface="Times New Roman" panose="02020603050405020304" pitchFamily="18" charset="0"/>
+                <a:cs typeface="Times New Roman" panose="02020603050405020304" pitchFamily="18" charset="0"/>
+              </a:rPr>
+              <a:t>conn</a:t>
+            </a:r>
+            <a:r>
               <a:rPr lang="pt-BR" sz="1600" dirty="0" err="1">
                 <a:latin typeface="Times New Roman" panose="02020603050405020304" pitchFamily="18" charset="0"/>
                 <a:cs typeface="Times New Roman" panose="02020603050405020304" pitchFamily="18" charset="0"/>
               </a:rPr>
-              <a:t>cur</a:t>
+              <a:t>.cursor</a:t>
             </a:r>
             <a:r>
               <a:rPr lang="pt-BR" sz="1600" dirty="0">
                 <a:latin typeface="Times New Roman" panose="02020603050405020304" pitchFamily="18" charset="0"/>
                 <a:cs typeface="Times New Roman" panose="02020603050405020304" pitchFamily="18" charset="0"/>
               </a:rPr>
-              <a:t> = </a:t>
-            </a:r>
-            <a:r>
-              <a:rPr lang="pt-BR" sz="1600" b="1" dirty="0" err="1">
+              <a:t>()</a:t>
+            </a:r>
+          </a:p>
+          <a:p>
+            <a:pPr marL="0" indent="0" algn="just">
+              <a:buNone/>
+            </a:pPr>
+            <a:r>
+              <a:rPr lang="pt-BR" sz="1600" dirty="0" err="1">
+                <a:latin typeface="Times New Roman" panose="02020603050405020304" pitchFamily="18" charset="0"/>
+                <a:cs typeface="Times New Roman" panose="02020603050405020304" pitchFamily="18" charset="0"/>
+              </a:rPr>
+              <a:t>cursor.execute</a:t>
+            </a:r>
+            <a:r>
+              <a:rPr lang="pt-BR" sz="1600" dirty="0">
+                <a:latin typeface="Times New Roman" panose="02020603050405020304" pitchFamily="18" charset="0"/>
+                <a:cs typeface="Times New Roman" panose="02020603050405020304" pitchFamily="18" charset="0"/>
+              </a:rPr>
+              <a:t>("</a:t>
+            </a:r>
+            <a:r>
+              <a:rPr lang="pt-BR" sz="1600" b="1" dirty="0">
+                <a:solidFill>
+                  <a:srgbClr val="FF0000"/>
+                </a:solidFill>
+                <a:latin typeface="Times New Roman" panose="02020603050405020304" pitchFamily="18" charset="0"/>
+                <a:cs typeface="Times New Roman" panose="02020603050405020304" pitchFamily="18" charset="0"/>
+              </a:rPr>
+              <a:t>SELECT</a:t>
+            </a:r>
+            <a:r>
+              <a:rPr lang="pt-BR" sz="1600" dirty="0">
+                <a:latin typeface="Times New Roman" panose="02020603050405020304" pitchFamily="18" charset="0"/>
+                <a:cs typeface="Times New Roman" panose="02020603050405020304" pitchFamily="18" charset="0"/>
+              </a:rPr>
+              <a:t> </a:t>
+            </a:r>
+            <a:r>
+              <a:rPr lang="pt-BR" sz="1600" dirty="0" err="1">
+                <a:latin typeface="Times New Roman" panose="02020603050405020304" pitchFamily="18" charset="0"/>
+                <a:cs typeface="Times New Roman" panose="02020603050405020304" pitchFamily="18" charset="0"/>
+              </a:rPr>
+              <a:t>current_database</a:t>
+            </a:r>
+            <a:r>
+              <a:rPr lang="pt-BR" sz="1600" dirty="0">
+                <a:latin typeface="Times New Roman" panose="02020603050405020304" pitchFamily="18" charset="0"/>
+                <a:cs typeface="Times New Roman" panose="02020603050405020304" pitchFamily="18" charset="0"/>
+              </a:rPr>
+              <a:t>(); ")</a:t>
+            </a:r>
+          </a:p>
+          <a:p>
+            <a:pPr marL="0" indent="0" algn="just">
+              <a:buNone/>
+            </a:pPr>
+            <a:r>
+              <a:rPr lang="pt-BR" sz="1600" dirty="0">
+                <a:latin typeface="Times New Roman" panose="02020603050405020304" pitchFamily="18" charset="0"/>
+                <a:cs typeface="Times New Roman" panose="02020603050405020304" pitchFamily="18" charset="0"/>
+              </a:rPr>
+              <a:t>linha = </a:t>
+            </a:r>
+            <a:r>
+              <a:rPr lang="pt-BR" sz="1600" dirty="0" err="1">
+                <a:latin typeface="Times New Roman" panose="02020603050405020304" pitchFamily="18" charset="0"/>
+                <a:cs typeface="Times New Roman" panose="02020603050405020304" pitchFamily="18" charset="0"/>
+              </a:rPr>
+              <a:t>cursor.fetchone</a:t>
+            </a:r>
+            <a:r>
+              <a:rPr lang="pt-BR" sz="1600" dirty="0">
+                <a:latin typeface="Times New Roman" panose="02020603050405020304" pitchFamily="18" charset="0"/>
+                <a:cs typeface="Times New Roman" panose="02020603050405020304" pitchFamily="18" charset="0"/>
+              </a:rPr>
+              <a:t>()</a:t>
+            </a:r>
+          </a:p>
+          <a:p>
+            <a:pPr marL="0" indent="0" algn="just">
+              <a:buNone/>
+            </a:pPr>
+            <a:r>
+              <a:rPr lang="pt-BR" sz="1600" dirty="0">
+                <a:latin typeface="Times New Roman" panose="02020603050405020304" pitchFamily="18" charset="0"/>
+                <a:cs typeface="Times New Roman" panose="02020603050405020304" pitchFamily="18" charset="0"/>
+              </a:rPr>
+              <a:t>print("conectado ao banco de dados: ", linha)</a:t>
+            </a:r>
+          </a:p>
+          <a:p>
+            <a:pPr marL="0" indent="0" algn="just">
+              <a:buNone/>
+            </a:pPr>
+            <a:r>
+              <a:rPr lang="pt-BR" sz="1600" dirty="0" err="1">
+                <a:latin typeface="Times New Roman" panose="02020603050405020304" pitchFamily="18" charset="0"/>
+                <a:cs typeface="Times New Roman" panose="02020603050405020304" pitchFamily="18" charset="0"/>
+              </a:rPr>
+              <a:t>if</a:t>
+            </a:r>
+            <a:r>
+              <a:rPr lang="pt-BR" sz="1600" dirty="0">
+                <a:latin typeface="Times New Roman" panose="02020603050405020304" pitchFamily="18" charset="0"/>
+                <a:cs typeface="Times New Roman" panose="02020603050405020304" pitchFamily="18" charset="0"/>
+              </a:rPr>
+              <a:t> </a:t>
+            </a:r>
+            <a:r>
+              <a:rPr lang="pt-BR" sz="1600" dirty="0" err="1">
                 <a:latin typeface="Times New Roman" panose="02020603050405020304" pitchFamily="18" charset="0"/>
                 <a:cs typeface="Times New Roman" panose="02020603050405020304" pitchFamily="18" charset="0"/>
               </a:rPr>
               <a:t>conn</a:t>
             </a:r>
             <a:r>
+              <a:rPr lang="pt-BR" sz="1600" dirty="0">
+                <a:latin typeface="Times New Roman" panose="02020603050405020304" pitchFamily="18" charset="0"/>
+                <a:cs typeface="Times New Roman" panose="02020603050405020304" pitchFamily="18" charset="0"/>
+              </a:rPr>
+              <a:t> </a:t>
+            </a:r>
+            <a:r>
               <a:rPr lang="pt-BR" sz="1600" dirty="0" err="1">
                 <a:latin typeface="Times New Roman" panose="02020603050405020304" pitchFamily="18" charset="0"/>
                 <a:cs typeface="Times New Roman" panose="02020603050405020304" pitchFamily="18" charset="0"/>
               </a:rPr>
-              <a:t>.cursor</a:t>
+              <a:t>and</a:t>
             </a:r>
             <a:r>
               <a:rPr lang="pt-BR" sz="1600" dirty="0">
                 <a:latin typeface="Times New Roman" panose="02020603050405020304" pitchFamily="18" charset="0"/>
                 <a:cs typeface="Times New Roman" panose="02020603050405020304" pitchFamily="18" charset="0"/>
               </a:rPr>
-              <a:t>()</a:t>
+              <a:t> </a:t>
+            </a:r>
+            <a:r>
+              <a:rPr lang="pt-BR" sz="1600" dirty="0" err="1">
+                <a:latin typeface="Times New Roman" panose="02020603050405020304" pitchFamily="18" charset="0"/>
+                <a:cs typeface="Times New Roman" panose="02020603050405020304" pitchFamily="18" charset="0"/>
+              </a:rPr>
+              <a:t>conn.closed</a:t>
+            </a:r>
+            <a:r>
+              <a:rPr lang="pt-BR" sz="1600" dirty="0">
+                <a:latin typeface="Times New Roman" panose="02020603050405020304" pitchFamily="18" charset="0"/>
+                <a:cs typeface="Times New Roman" panose="02020603050405020304" pitchFamily="18" charset="0"/>
+              </a:rPr>
+              <a:t> == 0: # testando se está conectado</a:t>
             </a:r>
           </a:p>
           <a:p>
@@ -7489,164 +7641,18 @@
               <a:buNone/>
             </a:pPr>
             <a:r>
+              <a:rPr lang="pt-BR" sz="1600" dirty="0">
+                <a:latin typeface="Times New Roman" panose="02020603050405020304" pitchFamily="18" charset="0"/>
+                <a:cs typeface="Times New Roman" panose="02020603050405020304" pitchFamily="18" charset="0"/>
+              </a:rPr>
+              <a:t>    </a:t>
+            </a:r>
+            <a:r>
               <a:rPr lang="pt-BR" sz="1600" dirty="0" err="1">
                 <a:latin typeface="Times New Roman" panose="02020603050405020304" pitchFamily="18" charset="0"/>
                 <a:cs typeface="Times New Roman" panose="02020603050405020304" pitchFamily="18" charset="0"/>
               </a:rPr>
-              <a:t>cur.execute</a:t>
-            </a:r>
-            <a:r>
-              <a:rPr lang="pt-BR" sz="1600" dirty="0">
-                <a:latin typeface="Times New Roman" panose="02020603050405020304" pitchFamily="18" charset="0"/>
-                <a:cs typeface="Times New Roman" panose="02020603050405020304" pitchFamily="18" charset="0"/>
-              </a:rPr>
-              <a:t>("</a:t>
-            </a:r>
-            <a:r>
-              <a:rPr lang="pt-BR" sz="1600" dirty="0" err="1">
-                <a:latin typeface="Times New Roman" panose="02020603050405020304" pitchFamily="18" charset="0"/>
-                <a:cs typeface="Times New Roman" panose="02020603050405020304" pitchFamily="18" charset="0"/>
-              </a:rPr>
-              <a:t>select</a:t>
-            </a:r>
-            <a:r>
-              <a:rPr lang="pt-BR" sz="1600" dirty="0">
-                <a:latin typeface="Times New Roman" panose="02020603050405020304" pitchFamily="18" charset="0"/>
-                <a:cs typeface="Times New Roman" panose="02020603050405020304" pitchFamily="18" charset="0"/>
-              </a:rPr>
-              <a:t> </a:t>
-            </a:r>
-            <a:r>
-              <a:rPr lang="pt-BR" sz="1600" dirty="0" err="1">
-                <a:latin typeface="Times New Roman" panose="02020603050405020304" pitchFamily="18" charset="0"/>
-                <a:cs typeface="Times New Roman" panose="02020603050405020304" pitchFamily="18" charset="0"/>
-              </a:rPr>
-              <a:t>current_database</a:t>
-            </a:r>
-            <a:r>
-              <a:rPr lang="pt-BR" sz="1600" dirty="0">
-                <a:latin typeface="Times New Roman" panose="02020603050405020304" pitchFamily="18" charset="0"/>
-                <a:cs typeface="Times New Roman" panose="02020603050405020304" pitchFamily="18" charset="0"/>
-              </a:rPr>
-              <a:t>(); ")</a:t>
-            </a:r>
-          </a:p>
-          <a:p>
-            <a:pPr marL="0" indent="0" algn="just">
-              <a:buNone/>
-            </a:pPr>
-            <a:r>
-              <a:rPr lang="pt-BR" sz="1600" dirty="0">
-                <a:latin typeface="Times New Roman" panose="02020603050405020304" pitchFamily="18" charset="0"/>
-                <a:cs typeface="Times New Roman" panose="02020603050405020304" pitchFamily="18" charset="0"/>
-              </a:rPr>
-              <a:t>linha = </a:t>
-            </a:r>
-            <a:r>
-              <a:rPr lang="pt-BR" sz="1600" dirty="0" err="1">
-                <a:latin typeface="Times New Roman" panose="02020603050405020304" pitchFamily="18" charset="0"/>
-                <a:cs typeface="Times New Roman" panose="02020603050405020304" pitchFamily="18" charset="0"/>
-              </a:rPr>
-              <a:t>cur.fetchone</a:t>
-            </a:r>
-            <a:r>
-              <a:rPr lang="pt-BR" sz="1600" dirty="0">
-                <a:latin typeface="Times New Roman" panose="02020603050405020304" pitchFamily="18" charset="0"/>
-                <a:cs typeface="Times New Roman" panose="02020603050405020304" pitchFamily="18" charset="0"/>
-              </a:rPr>
-              <a:t>()</a:t>
-            </a:r>
-          </a:p>
-          <a:p>
-            <a:pPr marL="0" indent="0" algn="just">
-              <a:buNone/>
-            </a:pPr>
-            <a:r>
-              <a:rPr lang="pt-BR" sz="1600" dirty="0">
-                <a:latin typeface="Times New Roman" panose="02020603050405020304" pitchFamily="18" charset="0"/>
-                <a:cs typeface="Times New Roman" panose="02020603050405020304" pitchFamily="18" charset="0"/>
-              </a:rPr>
-              <a:t>print("conectado ao banco de dados: ", linha)</a:t>
-            </a:r>
-          </a:p>
-          <a:p>
-            <a:pPr marL="0" indent="0" algn="just">
-              <a:buNone/>
-            </a:pPr>
-            <a:r>
-              <a:rPr lang="pt-BR" sz="1600" dirty="0" err="1">
-                <a:latin typeface="Times New Roman" panose="02020603050405020304" pitchFamily="18" charset="0"/>
-                <a:cs typeface="Times New Roman" panose="02020603050405020304" pitchFamily="18" charset="0"/>
-              </a:rPr>
-              <a:t>if</a:t>
-            </a:r>
-            <a:r>
-              <a:rPr lang="pt-BR" sz="1600" dirty="0">
-                <a:latin typeface="Times New Roman" panose="02020603050405020304" pitchFamily="18" charset="0"/>
-                <a:cs typeface="Times New Roman" panose="02020603050405020304" pitchFamily="18" charset="0"/>
-              </a:rPr>
-              <a:t> </a:t>
-            </a:r>
-            <a:r>
-              <a:rPr lang="pt-BR" sz="1600" dirty="0" err="1">
-                <a:latin typeface="Times New Roman" panose="02020603050405020304" pitchFamily="18" charset="0"/>
-                <a:cs typeface="Times New Roman" panose="02020603050405020304" pitchFamily="18" charset="0"/>
-              </a:rPr>
-              <a:t>conn</a:t>
-            </a:r>
-            <a:r>
-              <a:rPr lang="pt-BR" sz="1600" dirty="0">
-                <a:latin typeface="Times New Roman" panose="02020603050405020304" pitchFamily="18" charset="0"/>
-                <a:cs typeface="Times New Roman" panose="02020603050405020304" pitchFamily="18" charset="0"/>
-              </a:rPr>
-              <a:t> </a:t>
-            </a:r>
-            <a:r>
-              <a:rPr lang="pt-BR" sz="1600" dirty="0" err="1">
-                <a:latin typeface="Times New Roman" panose="02020603050405020304" pitchFamily="18" charset="0"/>
-                <a:cs typeface="Times New Roman" panose="02020603050405020304" pitchFamily="18" charset="0"/>
-              </a:rPr>
-              <a:t>and</a:t>
-            </a:r>
-            <a:r>
-              <a:rPr lang="pt-BR" sz="1600" dirty="0">
-                <a:latin typeface="Times New Roman" panose="02020603050405020304" pitchFamily="18" charset="0"/>
-                <a:cs typeface="Times New Roman" panose="02020603050405020304" pitchFamily="18" charset="0"/>
-              </a:rPr>
-              <a:t> </a:t>
-            </a:r>
-            <a:r>
-              <a:rPr lang="pt-BR" sz="1600" dirty="0" err="1">
-                <a:latin typeface="Times New Roman" panose="02020603050405020304" pitchFamily="18" charset="0"/>
-                <a:cs typeface="Times New Roman" panose="02020603050405020304" pitchFamily="18" charset="0"/>
-              </a:rPr>
-              <a:t>conn.closed</a:t>
-            </a:r>
-            <a:r>
-              <a:rPr lang="pt-BR" sz="1600" dirty="0">
-                <a:latin typeface="Times New Roman" panose="02020603050405020304" pitchFamily="18" charset="0"/>
-                <a:cs typeface="Times New Roman" panose="02020603050405020304" pitchFamily="18" charset="0"/>
-              </a:rPr>
-              <a:t> == 0: # testando se está conectado</a:t>
-            </a:r>
-          </a:p>
-          <a:p>
-            <a:pPr marL="0" indent="0" algn="just">
-              <a:buNone/>
-            </a:pPr>
-            <a:r>
-              <a:rPr lang="pt-BR" sz="1600" dirty="0">
-                <a:latin typeface="Times New Roman" panose="02020603050405020304" pitchFamily="18" charset="0"/>
-                <a:cs typeface="Times New Roman" panose="02020603050405020304" pitchFamily="18" charset="0"/>
-              </a:rPr>
-              <a:t>    </a:t>
-            </a:r>
-            <a:r>
-              <a:rPr lang="pt-BR" sz="1600" dirty="0" err="1">
-                <a:latin typeface="Times New Roman" panose="02020603050405020304" pitchFamily="18" charset="0"/>
-                <a:cs typeface="Times New Roman" panose="02020603050405020304" pitchFamily="18" charset="0"/>
-              </a:rPr>
-              <a:t>cur.close</a:t>
+              <a:t>cursor.close</a:t>
             </a:r>
             <a:r>
               <a:rPr lang="pt-BR" sz="1600" dirty="0">
@@ -7919,38 +7925,154 @@
               <a:buNone/>
             </a:pPr>
             <a:r>
+              <a:rPr lang="pt-BR" sz="1600" dirty="0">
+                <a:latin typeface="Times New Roman" panose="02020603050405020304" pitchFamily="18" charset="0"/>
+                <a:cs typeface="Times New Roman" panose="02020603050405020304" pitchFamily="18" charset="0"/>
+              </a:rPr>
+              <a:t>cursor = </a:t>
+            </a:r>
+            <a:r>
+              <a:rPr lang="pt-BR" sz="1600" b="1" dirty="0" err="1">
+                <a:latin typeface="Times New Roman" panose="02020603050405020304" pitchFamily="18" charset="0"/>
+                <a:cs typeface="Times New Roman" panose="02020603050405020304" pitchFamily="18" charset="0"/>
+              </a:rPr>
+              <a:t>conn</a:t>
+            </a:r>
+            <a:r>
               <a:rPr lang="pt-BR" sz="1600" dirty="0" err="1">
                 <a:latin typeface="Times New Roman" panose="02020603050405020304" pitchFamily="18" charset="0"/>
                 <a:cs typeface="Times New Roman" panose="02020603050405020304" pitchFamily="18" charset="0"/>
               </a:rPr>
-              <a:t>cur</a:t>
+              <a:t>.cursor</a:t>
             </a:r>
             <a:r>
               <a:rPr lang="pt-BR" sz="1600" dirty="0">
                 <a:latin typeface="Times New Roman" panose="02020603050405020304" pitchFamily="18" charset="0"/>
                 <a:cs typeface="Times New Roman" panose="02020603050405020304" pitchFamily="18" charset="0"/>
               </a:rPr>
-              <a:t> = </a:t>
-            </a:r>
-            <a:r>
-              <a:rPr lang="pt-BR" sz="1600" b="1" dirty="0" err="1">
-                <a:latin typeface="Times New Roman" panose="02020603050405020304" pitchFamily="18" charset="0"/>
-                <a:cs typeface="Times New Roman" panose="02020603050405020304" pitchFamily="18" charset="0"/>
-              </a:rPr>
-              <a:t>conn</a:t>
-            </a:r>
+              <a:t>()</a:t>
+            </a:r>
+          </a:p>
+          <a:p>
+            <a:pPr marL="0" indent="0" algn="just">
+              <a:buNone/>
+            </a:pPr>
             <a:r>
               <a:rPr lang="pt-BR" sz="1600" dirty="0" err="1">
                 <a:latin typeface="Times New Roman" panose="02020603050405020304" pitchFamily="18" charset="0"/>
                 <a:cs typeface="Times New Roman" panose="02020603050405020304" pitchFamily="18" charset="0"/>
               </a:rPr>
-              <a:t>.cursor</a:t>
+              <a:t>sql</a:t>
             </a:r>
             <a:r>
               <a:rPr lang="pt-BR" sz="1600" dirty="0">
                 <a:latin typeface="Times New Roman" panose="02020603050405020304" pitchFamily="18" charset="0"/>
                 <a:cs typeface="Times New Roman" panose="02020603050405020304" pitchFamily="18" charset="0"/>
               </a:rPr>
+              <a:t> = “</a:t>
+            </a:r>
+            <a:r>
+              <a:rPr lang="pt-BR" sz="1600" b="1" dirty="0">
+                <a:solidFill>
+                  <a:srgbClr val="FF0000"/>
+                </a:solidFill>
+                <a:latin typeface="Times New Roman" panose="02020603050405020304" pitchFamily="18" charset="0"/>
+                <a:cs typeface="Times New Roman" panose="02020603050405020304" pitchFamily="18" charset="0"/>
+              </a:rPr>
+              <a:t>SELECT</a:t>
+            </a:r>
+            <a:r>
+              <a:rPr lang="pt-BR" sz="1600" dirty="0">
+                <a:latin typeface="Times New Roman" panose="02020603050405020304" pitchFamily="18" charset="0"/>
+                <a:cs typeface="Times New Roman" panose="02020603050405020304" pitchFamily="18" charset="0"/>
+              </a:rPr>
+              <a:t> * </a:t>
+            </a:r>
+            <a:r>
+              <a:rPr lang="pt-BR" sz="1600" dirty="0" err="1">
+                <a:latin typeface="Times New Roman" panose="02020603050405020304" pitchFamily="18" charset="0"/>
+                <a:cs typeface="Times New Roman" panose="02020603050405020304" pitchFamily="18" charset="0"/>
+              </a:rPr>
+              <a:t>from</a:t>
+            </a:r>
+            <a:r>
+              <a:rPr lang="pt-BR" sz="1600" dirty="0">
+                <a:latin typeface="Times New Roman" panose="02020603050405020304" pitchFamily="18" charset="0"/>
+                <a:cs typeface="Times New Roman" panose="02020603050405020304" pitchFamily="18" charset="0"/>
+              </a:rPr>
+              <a:t> </a:t>
+            </a:r>
+            <a:r>
+              <a:rPr lang="pt-BR" sz="1600" dirty="0" err="1">
+                <a:latin typeface="Times New Roman" panose="02020603050405020304" pitchFamily="18" charset="0"/>
+                <a:cs typeface="Times New Roman" panose="02020603050405020304" pitchFamily="18" charset="0"/>
+              </a:rPr>
+              <a:t>department</a:t>
+            </a:r>
+            <a:r>
+              <a:rPr lang="pt-BR" sz="1600" dirty="0">
+                <a:latin typeface="Times New Roman" panose="02020603050405020304" pitchFamily="18" charset="0"/>
+                <a:cs typeface="Times New Roman" panose="02020603050405020304" pitchFamily="18" charset="0"/>
+              </a:rPr>
+              <a:t>"</a:t>
+            </a:r>
+          </a:p>
+          <a:p>
+            <a:pPr marL="0" indent="0" algn="just">
+              <a:buNone/>
+            </a:pPr>
+            <a:r>
+              <a:rPr lang="pt-BR" sz="1600" dirty="0" err="1">
+                <a:latin typeface="Times New Roman" panose="02020603050405020304" pitchFamily="18" charset="0"/>
+                <a:cs typeface="Times New Roman" panose="02020603050405020304" pitchFamily="18" charset="0"/>
+              </a:rPr>
+              <a:t>cursor.execute</a:t>
+            </a:r>
+            <a:r>
+              <a:rPr lang="pt-BR" sz="1600" dirty="0">
+                <a:latin typeface="Times New Roman" panose="02020603050405020304" pitchFamily="18" charset="0"/>
+                <a:cs typeface="Times New Roman" panose="02020603050405020304" pitchFamily="18" charset="0"/>
+              </a:rPr>
+              <a:t>(</a:t>
+            </a:r>
+            <a:r>
+              <a:rPr lang="pt-BR" sz="1600" dirty="0" err="1">
+                <a:latin typeface="Times New Roman" panose="02020603050405020304" pitchFamily="18" charset="0"/>
+                <a:cs typeface="Times New Roman" panose="02020603050405020304" pitchFamily="18" charset="0"/>
+              </a:rPr>
+              <a:t>sql</a:t>
+            </a:r>
+            <a:r>
+              <a:rPr lang="pt-BR" sz="1600" dirty="0">
+                <a:latin typeface="Times New Roman" panose="02020603050405020304" pitchFamily="18" charset="0"/>
+                <a:cs typeface="Times New Roman" panose="02020603050405020304" pitchFamily="18" charset="0"/>
+              </a:rPr>
+              <a:t>)</a:t>
+            </a:r>
+          </a:p>
+          <a:p>
+            <a:pPr marL="0" indent="0" algn="just">
+              <a:buNone/>
+            </a:pPr>
+            <a:r>
+              <a:rPr lang="pt-BR" sz="1600" dirty="0">
+                <a:latin typeface="Times New Roman" panose="02020603050405020304" pitchFamily="18" charset="0"/>
+                <a:cs typeface="Times New Roman" panose="02020603050405020304" pitchFamily="18" charset="0"/>
+              </a:rPr>
+              <a:t>linhas = </a:t>
+            </a:r>
+            <a:r>
+              <a:rPr lang="pt-BR" sz="1600" dirty="0" err="1">
+                <a:latin typeface="Times New Roman" panose="02020603050405020304" pitchFamily="18" charset="0"/>
+                <a:cs typeface="Times New Roman" panose="02020603050405020304" pitchFamily="18" charset="0"/>
+              </a:rPr>
+              <a:t>cursor.fetchall</a:t>
+            </a:r>
+            <a:r>
+              <a:rPr lang="pt-BR" sz="1600" dirty="0">
+                <a:latin typeface="Times New Roman" panose="02020603050405020304" pitchFamily="18" charset="0"/>
+                <a:cs typeface="Times New Roman" panose="02020603050405020304" pitchFamily="18" charset="0"/>
+              </a:rPr>
               <a:t>()</a:t>
             </a:r>
           </a:p>
@@ -7959,155 +8081,35 @@
               <a:buNone/>
             </a:pPr>
             <a:r>
+              <a:rPr lang="pt-BR" sz="1600" dirty="0">
+                <a:latin typeface="Times New Roman" panose="02020603050405020304" pitchFamily="18" charset="0"/>
+                <a:cs typeface="Times New Roman" panose="02020603050405020304" pitchFamily="18" charset="0"/>
+              </a:rPr>
+              <a:t>for linha in linhas:</a:t>
+            </a:r>
+          </a:p>
+          <a:p>
+            <a:pPr marL="0" indent="0" algn="just">
+              <a:buNone/>
+            </a:pPr>
+            <a:r>
+              <a:rPr lang="pt-BR" sz="1600" dirty="0">
+                <a:latin typeface="Times New Roman" panose="02020603050405020304" pitchFamily="18" charset="0"/>
+                <a:cs typeface="Times New Roman" panose="02020603050405020304" pitchFamily="18" charset="0"/>
+              </a:rPr>
+              <a:t>    print(linha)</a:t>
+            </a:r>
+          </a:p>
+          <a:p>
+            <a:pPr marL="0" indent="0" algn="just">
+              <a:buNone/>
+            </a:pPr>
+            <a:r>
               <a:rPr lang="pt-BR" sz="1600" dirty="0" err="1">
                 <a:latin typeface="Times New Roman" panose="02020603050405020304" pitchFamily="18" charset="0"/>
                 <a:cs typeface="Times New Roman" panose="02020603050405020304" pitchFamily="18" charset="0"/>
               </a:rPr>
-              <a:t>sql</a:t>
-            </a:r>
-            <a:r>
-              <a:rPr lang="pt-BR" sz="1600" dirty="0">
-                <a:latin typeface="Times New Roman" panose="02020603050405020304" pitchFamily="18" charset="0"/>
-                <a:cs typeface="Times New Roman" panose="02020603050405020304" pitchFamily="18" charset="0"/>
-              </a:rPr>
-              <a:t> = "</a:t>
-            </a:r>
-            <a:r>
-              <a:rPr lang="pt-BR" sz="1600" dirty="0" err="1">
-                <a:latin typeface="Times New Roman" panose="02020603050405020304" pitchFamily="18" charset="0"/>
-                <a:cs typeface="Times New Roman" panose="02020603050405020304" pitchFamily="18" charset="0"/>
-              </a:rPr>
-              <a:t>select</a:t>
-            </a:r>
-            <a:r>
-              <a:rPr lang="pt-BR" sz="1600" dirty="0">
-                <a:latin typeface="Times New Roman" panose="02020603050405020304" pitchFamily="18" charset="0"/>
-                <a:cs typeface="Times New Roman" panose="02020603050405020304" pitchFamily="18" charset="0"/>
-              </a:rPr>
-              <a:t> * </a:t>
-            </a:r>
-            <a:r>
-              <a:rPr lang="pt-BR" sz="1600" dirty="0" err="1">
-                <a:latin typeface="Times New Roman" panose="02020603050405020304" pitchFamily="18" charset="0"/>
-                <a:cs typeface="Times New Roman" panose="02020603050405020304" pitchFamily="18" charset="0"/>
-              </a:rPr>
-              <a:t>from</a:t>
-            </a:r>
-            <a:r>
-              <a:rPr lang="pt-BR" sz="1600" dirty="0">
-                <a:latin typeface="Times New Roman" panose="02020603050405020304" pitchFamily="18" charset="0"/>
-                <a:cs typeface="Times New Roman" panose="02020603050405020304" pitchFamily="18" charset="0"/>
-              </a:rPr>
-              <a:t> </a:t>
-            </a:r>
-            <a:r>
-              <a:rPr lang="pt-BR" sz="1600" dirty="0" err="1">
-                <a:latin typeface="Times New Roman" panose="02020603050405020304" pitchFamily="18" charset="0"/>
-                <a:cs typeface="Times New Roman" panose="02020603050405020304" pitchFamily="18" charset="0"/>
-              </a:rPr>
-              <a:t>department</a:t>
-            </a:r>
-            <a:r>
-              <a:rPr lang="pt-BR" sz="1600" dirty="0">
-                <a:latin typeface="Times New Roman" panose="02020603050405020304" pitchFamily="18" charset="0"/>
-                <a:cs typeface="Times New Roman" panose="02020603050405020304" pitchFamily="18" charset="0"/>
-              </a:rPr>
-              <a:t>"</a:t>
-            </a:r>
-          </a:p>
-          <a:p>
-            <a:pPr marL="0" indent="0" algn="just">
-              <a:buNone/>
-            </a:pPr>
-            <a:r>
-              <a:rPr lang="pt-BR" sz="1600" dirty="0" err="1">
-                <a:latin typeface="Times New Roman" panose="02020603050405020304" pitchFamily="18" charset="0"/>
-                <a:cs typeface="Times New Roman" panose="02020603050405020304" pitchFamily="18" charset="0"/>
-              </a:rPr>
-              <a:t>cur.execute</a:t>
-            </a:r>
-            <a:r>
-              <a:rPr lang="pt-BR" sz="1600" dirty="0">
-                <a:latin typeface="Times New Roman" panose="02020603050405020304" pitchFamily="18" charset="0"/>
-                <a:cs typeface="Times New Roman" panose="02020603050405020304" pitchFamily="18" charset="0"/>
-              </a:rPr>
-              <a:t>(</a:t>
-            </a:r>
-            <a:r>
-              <a:rPr lang="pt-BR" sz="1600" dirty="0" err="1">
-                <a:latin typeface="Times New Roman" panose="02020603050405020304" pitchFamily="18" charset="0"/>
-                <a:cs typeface="Times New Roman" panose="02020603050405020304" pitchFamily="18" charset="0"/>
-              </a:rPr>
-              <a:t>sql</a:t>
-            </a:r>
-            <a:r>
-              <a:rPr lang="pt-BR" sz="1600" dirty="0">
-                <a:latin typeface="Times New Roman" panose="02020603050405020304" pitchFamily="18" charset="0"/>
-                <a:cs typeface="Times New Roman" panose="02020603050405020304" pitchFamily="18" charset="0"/>
-              </a:rPr>
-              <a:t>)</a:t>
-            </a:r>
-          </a:p>
-          <a:p>
-            <a:pPr marL="0" indent="0" algn="just">
-              <a:buNone/>
-            </a:pPr>
-            <a:r>
-              <a:rPr lang="pt-BR" sz="1600" dirty="0">
-                <a:latin typeface="Times New Roman" panose="02020603050405020304" pitchFamily="18" charset="0"/>
-                <a:cs typeface="Times New Roman" panose="02020603050405020304" pitchFamily="18" charset="0"/>
-              </a:rPr>
-              <a:t>linhas = </a:t>
-            </a:r>
-            <a:r>
-              <a:rPr lang="pt-BR" sz="1600" dirty="0" err="1">
-                <a:latin typeface="Times New Roman" panose="02020603050405020304" pitchFamily="18" charset="0"/>
-                <a:cs typeface="Times New Roman" panose="02020603050405020304" pitchFamily="18" charset="0"/>
-              </a:rPr>
-              <a:t>cur.fetchall</a:t>
-            </a:r>
-            <a:r>
-              <a:rPr lang="pt-BR" sz="1600" dirty="0">
-                <a:latin typeface="Times New Roman" panose="02020603050405020304" pitchFamily="18" charset="0"/>
-                <a:cs typeface="Times New Roman" panose="02020603050405020304" pitchFamily="18" charset="0"/>
-              </a:rPr>
-              <a:t>()</a:t>
-            </a:r>
-          </a:p>
-          <a:p>
-            <a:pPr marL="0" indent="0" algn="just">
-              <a:buNone/>
-            </a:pPr>
-            <a:r>
-              <a:rPr lang="pt-BR" sz="1600" dirty="0">
-                <a:latin typeface="Times New Roman" panose="02020603050405020304" pitchFamily="18" charset="0"/>
-                <a:cs typeface="Times New Roman" panose="02020603050405020304" pitchFamily="18" charset="0"/>
-              </a:rPr>
-              <a:t>for linha in linhas:</a:t>
-            </a:r>
-          </a:p>
-          <a:p>
-            <a:pPr marL="0" indent="0" algn="just">
-              <a:buNone/>
-            </a:pPr>
-            <a:r>
-              <a:rPr lang="pt-BR" sz="1600" dirty="0">
-                <a:latin typeface="Times New Roman" panose="02020603050405020304" pitchFamily="18" charset="0"/>
-                <a:cs typeface="Times New Roman" panose="02020603050405020304" pitchFamily="18" charset="0"/>
-              </a:rPr>
-              <a:t>    print(linha)</a:t>
-            </a:r>
-          </a:p>
-          <a:p>
-            <a:pPr marL="0" indent="0" algn="just">
-              <a:buNone/>
-            </a:pPr>
-            <a:r>
-              <a:rPr lang="pt-BR" sz="1600" dirty="0" err="1">
-                <a:latin typeface="Times New Roman" panose="02020603050405020304" pitchFamily="18" charset="0"/>
-                <a:cs typeface="Times New Roman" panose="02020603050405020304" pitchFamily="18" charset="0"/>
-              </a:rPr>
-              <a:t>cur.close</a:t>
+              <a:t>cursor.close</a:t>
             </a:r>
             <a:r>
               <a:rPr lang="pt-BR" sz="1600" dirty="0">
@@ -8428,7 +8430,24 @@
                 <a:latin typeface="Times New Roman" panose="02020603050405020304" pitchFamily="18" charset="0"/>
                 <a:cs typeface="Times New Roman" panose="02020603050405020304" pitchFamily="18" charset="0"/>
               </a:rPr>
-              <a:t> = "INSERT INTO </a:t>
+              <a:t> = "</a:t>
+            </a:r>
+            <a:r>
+              <a:rPr lang="pt-BR" sz="1600" b="1" dirty="0">
+                <a:solidFill>
+                  <a:srgbClr val="FF0000"/>
+                </a:solidFill>
+                <a:latin typeface="Times New Roman" panose="02020603050405020304" pitchFamily="18" charset="0"/>
+                <a:cs typeface="Times New Roman" panose="02020603050405020304" pitchFamily="18" charset="0"/>
+              </a:rPr>
+              <a:t>INSERT</a:t>
+            </a:r>
+            <a:r>
+              <a:rPr lang="pt-BR" sz="1600" dirty="0">
+                <a:latin typeface="Times New Roman" panose="02020603050405020304" pitchFamily="18" charset="0"/>
+                <a:cs typeface="Times New Roman" panose="02020603050405020304" pitchFamily="18" charset="0"/>
+              </a:rPr>
+              <a:t> INTO </a:t>
             </a:r>
             <a:r>
               <a:rPr lang="pt-BR" sz="1600" dirty="0" err="1">
@@ -8501,7 +8520,14 @@
                 <a:latin typeface="Times New Roman" panose="02020603050405020304" pitchFamily="18" charset="0"/>
                 <a:cs typeface="Times New Roman" panose="02020603050405020304" pitchFamily="18" charset="0"/>
               </a:rPr>
-              <a:t>conn.commit</a:t>
+              <a:t>conn.</a:t>
+            </a:r>
+            <a:r>
+              <a:rPr lang="pt-BR" sz="1600" b="1" dirty="0" err="1">
+                <a:latin typeface="Times New Roman" panose="02020603050405020304" pitchFamily="18" charset="0"/>
+                <a:cs typeface="Times New Roman" panose="02020603050405020304" pitchFamily="18" charset="0"/>
+              </a:rPr>
+              <a:t>commit</a:t>
             </a:r>
             <a:r>
               <a:rPr lang="pt-BR" sz="1600" dirty="0">
@@ -8688,11 +8714,87 @@
               <a:buNone/>
             </a:pPr>
             <a:r>
+              <a:rPr lang="pt-BR" sz="1400" b="1" dirty="0">
+                <a:solidFill>
+                  <a:srgbClr val="FF0000"/>
+                </a:solidFill>
+                <a:latin typeface="Times New Roman" panose="02020603050405020304" pitchFamily="18" charset="0"/>
+                <a:cs typeface="Times New Roman" panose="02020603050405020304" pitchFamily="18" charset="0"/>
+              </a:rPr>
+              <a:t>manter as três linhas anteriores </a:t>
+            </a:r>
+            <a:r>
+              <a:rPr lang="pt-BR" sz="1400" b="1" dirty="0" err="1">
+                <a:solidFill>
+                  <a:srgbClr val="FF0000"/>
+                </a:solidFill>
+                <a:latin typeface="Times New Roman" panose="02020603050405020304" pitchFamily="18" charset="0"/>
+                <a:cs typeface="Times New Roman" panose="02020603050405020304" pitchFamily="18" charset="0"/>
+              </a:rPr>
+              <a:t>import</a:t>
+            </a:r>
+            <a:r>
+              <a:rPr lang="pt-BR" sz="1400" b="1" dirty="0">
+                <a:solidFill>
+                  <a:srgbClr val="FF0000"/>
+                </a:solidFill>
+                <a:latin typeface="Times New Roman" panose="02020603050405020304" pitchFamily="18" charset="0"/>
+                <a:cs typeface="Times New Roman" panose="02020603050405020304" pitchFamily="18" charset="0"/>
+              </a:rPr>
+              <a:t>, </a:t>
+            </a:r>
+            <a:r>
+              <a:rPr lang="pt-BR" sz="1400" b="1" dirty="0" err="1">
+                <a:solidFill>
+                  <a:srgbClr val="FF0000"/>
+                </a:solidFill>
+                <a:latin typeface="Times New Roman" panose="02020603050405020304" pitchFamily="18" charset="0"/>
+                <a:cs typeface="Times New Roman" panose="02020603050405020304" pitchFamily="18" charset="0"/>
+              </a:rPr>
+              <a:t>conn</a:t>
+            </a:r>
+            <a:r>
+              <a:rPr lang="pt-BR" sz="1400" b="1" dirty="0">
+                <a:solidFill>
+                  <a:srgbClr val="FF0000"/>
+                </a:solidFill>
+                <a:latin typeface="Times New Roman" panose="02020603050405020304" pitchFamily="18" charset="0"/>
+                <a:cs typeface="Times New Roman" panose="02020603050405020304" pitchFamily="18" charset="0"/>
+              </a:rPr>
+              <a:t>, cursor </a:t>
+            </a:r>
+          </a:p>
+          <a:p>
+            <a:pPr marL="0" indent="0" algn="just">
+              <a:buNone/>
+            </a:pPr>
+            <a:r>
+              <a:rPr lang="pt-BR" sz="1400" dirty="0" err="1">
+                <a:latin typeface="Times New Roman" panose="02020603050405020304" pitchFamily="18" charset="0"/>
+                <a:cs typeface="Times New Roman" panose="02020603050405020304" pitchFamily="18" charset="0"/>
+              </a:rPr>
+              <a:t>id_dep</a:t>
+            </a:r>
+            <a:r>
               <a:rPr lang="pt-BR" sz="1400" dirty="0">
                 <a:latin typeface="Times New Roman" panose="02020603050405020304" pitchFamily="18" charset="0"/>
                 <a:cs typeface="Times New Roman" panose="02020603050405020304" pitchFamily="18" charset="0"/>
               </a:rPr>
-              <a:t>...</a:t>
+              <a:t> = </a:t>
+            </a:r>
+            <a:r>
+              <a:rPr lang="pt-BR" sz="1400" dirty="0" err="1">
+                <a:latin typeface="Times New Roman" panose="02020603050405020304" pitchFamily="18" charset="0"/>
+                <a:cs typeface="Times New Roman" panose="02020603050405020304" pitchFamily="18" charset="0"/>
+              </a:rPr>
+              <a:t>int</a:t>
+            </a:r>
+            <a:r>
+              <a:rPr lang="pt-BR" sz="1400" dirty="0">
+                <a:latin typeface="Times New Roman" panose="02020603050405020304" pitchFamily="18" charset="0"/>
+                <a:cs typeface="Times New Roman" panose="02020603050405020304" pitchFamily="18" charset="0"/>
+              </a:rPr>
+              <a:t>(input("Digite o ID do departamento: "))</a:t>
             </a:r>
           </a:p>
           <a:p>
@@ -8704,73 +8806,57 @@
                 <a:latin typeface="Times New Roman" panose="02020603050405020304" pitchFamily="18" charset="0"/>
                 <a:cs typeface="Times New Roman" panose="02020603050405020304" pitchFamily="18" charset="0"/>
               </a:rPr>
-              <a:t>id_dep</a:t>
+              <a:t>novo_nome</a:t>
             </a:r>
             <a:r>
               <a:rPr lang="pt-BR" sz="1400" dirty="0">
                 <a:latin typeface="Times New Roman" panose="02020603050405020304" pitchFamily="18" charset="0"/>
                 <a:cs typeface="Times New Roman" panose="02020603050405020304" pitchFamily="18" charset="0"/>
               </a:rPr>
-              <a:t> = </a:t>
-            </a:r>
+              <a:t> = input("Digite o novo nome: ")</a:t>
+            </a:r>
+          </a:p>
+          <a:p>
+            <a:pPr marL="0" indent="0" algn="just">
+              <a:buNone/>
+            </a:pPr>
             <a:r>
               <a:rPr lang="pt-BR" sz="1400" dirty="0" err="1">
                 <a:latin typeface="Times New Roman" panose="02020603050405020304" pitchFamily="18" charset="0"/>
                 <a:cs typeface="Times New Roman" panose="02020603050405020304" pitchFamily="18" charset="0"/>
               </a:rPr>
-              <a:t>int</a:t>
+              <a:t>sql</a:t>
             </a:r>
             <a:r>
               <a:rPr lang="pt-BR" sz="1400" dirty="0">
                 <a:latin typeface="Times New Roman" panose="02020603050405020304" pitchFamily="18" charset="0"/>
                 <a:cs typeface="Times New Roman" panose="02020603050405020304" pitchFamily="18" charset="0"/>
               </a:rPr>
-              <a:t>(input("Digite o ID do departamento: "))</a:t>
-            </a:r>
-          </a:p>
-          <a:p>
-            <a:pPr marL="0" indent="0" algn="just">
-              <a:buNone/>
-            </a:pPr>
+              <a:t> = "</a:t>
+            </a:r>
+            <a:r>
+              <a:rPr lang="pt-BR" sz="1400" b="1" dirty="0">
+                <a:solidFill>
+                  <a:srgbClr val="FF0000"/>
+                </a:solidFill>
+                <a:latin typeface="Times New Roman" panose="02020603050405020304" pitchFamily="18" charset="0"/>
+                <a:cs typeface="Times New Roman" panose="02020603050405020304" pitchFamily="18" charset="0"/>
+              </a:rPr>
+              <a:t>UPDATE</a:t>
+            </a:r>
+            <a:r>
+              <a:rPr lang="pt-BR" sz="1400" dirty="0">
+                <a:latin typeface="Times New Roman" panose="02020603050405020304" pitchFamily="18" charset="0"/>
+                <a:cs typeface="Times New Roman" panose="02020603050405020304" pitchFamily="18" charset="0"/>
+              </a:rPr>
+              <a:t> </a:t>
+            </a:r>
             <a:r>
               <a:rPr lang="pt-BR" sz="1400" dirty="0" err="1">
                 <a:latin typeface="Times New Roman" panose="02020603050405020304" pitchFamily="18" charset="0"/>
                 <a:cs typeface="Times New Roman" panose="02020603050405020304" pitchFamily="18" charset="0"/>
               </a:rPr>
-              <a:t>novo_nome</a:t>
-            </a:r>
-            <a:r>
-              <a:rPr lang="pt-BR" sz="1400" dirty="0">
-                <a:latin typeface="Times New Roman" panose="02020603050405020304" pitchFamily="18" charset="0"/>
-                <a:cs typeface="Times New Roman" panose="02020603050405020304" pitchFamily="18" charset="0"/>
-              </a:rPr>
-              <a:t> = input("Digite o novo nome: ")</a:t>
-            </a:r>
-          </a:p>
-          <a:p>
-            <a:pPr marL="0" indent="0" algn="just">
-              <a:buNone/>
-            </a:pPr>
-            <a:r>
-              <a:rPr lang="pt-BR" sz="1400" dirty="0" err="1">
-                <a:latin typeface="Times New Roman" panose="02020603050405020304" pitchFamily="18" charset="0"/>
-                <a:cs typeface="Times New Roman" panose="02020603050405020304" pitchFamily="18" charset="0"/>
-              </a:rPr>
-              <a:t>sql</a:t>
-            </a:r>
-            <a:r>
-              <a:rPr lang="pt-BR" sz="1400" dirty="0">
-                <a:latin typeface="Times New Roman" panose="02020603050405020304" pitchFamily="18" charset="0"/>
-                <a:cs typeface="Times New Roman" panose="02020603050405020304" pitchFamily="18" charset="0"/>
-              </a:rPr>
-              <a:t> = "UPDATE </a:t>
-            </a:r>
-            <a:r>
-              <a:rPr lang="pt-BR" sz="1400" dirty="0" err="1">
-                <a:latin typeface="Times New Roman" panose="02020603050405020304" pitchFamily="18" charset="0"/>
-                <a:cs typeface="Times New Roman" panose="02020603050405020304" pitchFamily="18" charset="0"/>
-              </a:rPr>
-              <a:t>departament</a:t>
+              <a:t>department</a:t>
             </a:r>
             <a:r>
               <a:rPr lang="pt-BR" sz="1400" dirty="0">
@@ -9127,11 +9213,87 @@
               <a:buNone/>
             </a:pPr>
             <a:r>
+              <a:rPr lang="pt-BR" sz="1400" b="1" dirty="0">
+                <a:solidFill>
+                  <a:srgbClr val="FF0000"/>
+                </a:solidFill>
+                <a:latin typeface="Times New Roman" panose="02020603050405020304" pitchFamily="18" charset="0"/>
+                <a:cs typeface="Times New Roman" panose="02020603050405020304" pitchFamily="18" charset="0"/>
+              </a:rPr>
+              <a:t>manter as três linhas anteriores </a:t>
+            </a:r>
+            <a:r>
+              <a:rPr lang="pt-BR" sz="1400" b="1" dirty="0" err="1">
+                <a:solidFill>
+                  <a:srgbClr val="FF0000"/>
+                </a:solidFill>
+                <a:latin typeface="Times New Roman" panose="02020603050405020304" pitchFamily="18" charset="0"/>
+                <a:cs typeface="Times New Roman" panose="02020603050405020304" pitchFamily="18" charset="0"/>
+              </a:rPr>
+              <a:t>import</a:t>
+            </a:r>
+            <a:r>
+              <a:rPr lang="pt-BR" sz="1400" b="1" dirty="0">
+                <a:solidFill>
+                  <a:srgbClr val="FF0000"/>
+                </a:solidFill>
+                <a:latin typeface="Times New Roman" panose="02020603050405020304" pitchFamily="18" charset="0"/>
+                <a:cs typeface="Times New Roman" panose="02020603050405020304" pitchFamily="18" charset="0"/>
+              </a:rPr>
+              <a:t>, </a:t>
+            </a:r>
+            <a:r>
+              <a:rPr lang="pt-BR" sz="1400" b="1" dirty="0" err="1">
+                <a:solidFill>
+                  <a:srgbClr val="FF0000"/>
+                </a:solidFill>
+                <a:latin typeface="Times New Roman" panose="02020603050405020304" pitchFamily="18" charset="0"/>
+                <a:cs typeface="Times New Roman" panose="02020603050405020304" pitchFamily="18" charset="0"/>
+              </a:rPr>
+              <a:t>conn</a:t>
+            </a:r>
+            <a:r>
+              <a:rPr lang="pt-BR" sz="1400" b="1" dirty="0">
+                <a:solidFill>
+                  <a:srgbClr val="FF0000"/>
+                </a:solidFill>
+                <a:latin typeface="Times New Roman" panose="02020603050405020304" pitchFamily="18" charset="0"/>
+                <a:cs typeface="Times New Roman" panose="02020603050405020304" pitchFamily="18" charset="0"/>
+              </a:rPr>
+              <a:t>, cursor </a:t>
+            </a:r>
+          </a:p>
+          <a:p>
+            <a:pPr marL="0" indent="0" algn="just">
+              <a:buNone/>
+            </a:pPr>
+            <a:r>
+              <a:rPr lang="pt-BR" sz="1400" dirty="0" err="1">
+                <a:latin typeface="Times New Roman" panose="02020603050405020304" pitchFamily="18" charset="0"/>
+                <a:cs typeface="Times New Roman" panose="02020603050405020304" pitchFamily="18" charset="0"/>
+              </a:rPr>
+              <a:t>id_dep</a:t>
+            </a:r>
+            <a:r>
               <a:rPr lang="pt-BR" sz="1400" dirty="0">
                 <a:latin typeface="Times New Roman" panose="02020603050405020304" pitchFamily="18" charset="0"/>
                 <a:cs typeface="Times New Roman" panose="02020603050405020304" pitchFamily="18" charset="0"/>
               </a:rPr>
-              <a:t>...</a:t>
+              <a:t> = </a:t>
+            </a:r>
+            <a:r>
+              <a:rPr lang="pt-BR" sz="1400" dirty="0" err="1">
+                <a:latin typeface="Times New Roman" panose="02020603050405020304" pitchFamily="18" charset="0"/>
+                <a:cs typeface="Times New Roman" panose="02020603050405020304" pitchFamily="18" charset="0"/>
+              </a:rPr>
+              <a:t>int</a:t>
+            </a:r>
+            <a:r>
+              <a:rPr lang="pt-BR" sz="1400" dirty="0">
+                <a:latin typeface="Times New Roman" panose="02020603050405020304" pitchFamily="18" charset="0"/>
+                <a:cs typeface="Times New Roman" panose="02020603050405020304" pitchFamily="18" charset="0"/>
+              </a:rPr>
+              <a:t>(input("Digite o ID do departamento para deletar: "))</a:t>
             </a:r>
           </a:p>
           <a:p>
@@ -9143,54 +9305,38 @@
                 <a:latin typeface="Times New Roman" panose="02020603050405020304" pitchFamily="18" charset="0"/>
                 <a:cs typeface="Times New Roman" panose="02020603050405020304" pitchFamily="18" charset="0"/>
               </a:rPr>
-              <a:t>id_dep</a:t>
+              <a:t>sql</a:t>
             </a:r>
             <a:r>
               <a:rPr lang="pt-BR" sz="1400" dirty="0">
                 <a:latin typeface="Times New Roman" panose="02020603050405020304" pitchFamily="18" charset="0"/>
                 <a:cs typeface="Times New Roman" panose="02020603050405020304" pitchFamily="18" charset="0"/>
               </a:rPr>
-              <a:t> = </a:t>
+              <a:t> = "</a:t>
+            </a:r>
+            <a:r>
+              <a:rPr lang="pt-BR" sz="1400" b="1" dirty="0">
+                <a:solidFill>
+                  <a:srgbClr val="FF0000"/>
+                </a:solidFill>
+                <a:latin typeface="Times New Roman" panose="02020603050405020304" pitchFamily="18" charset="0"/>
+                <a:cs typeface="Times New Roman" panose="02020603050405020304" pitchFamily="18" charset="0"/>
+              </a:rPr>
+              <a:t>DELETE</a:t>
+            </a:r>
+            <a:r>
+              <a:rPr lang="pt-BR" sz="1400" dirty="0">
+                <a:latin typeface="Times New Roman" panose="02020603050405020304" pitchFamily="18" charset="0"/>
+                <a:cs typeface="Times New Roman" panose="02020603050405020304" pitchFamily="18" charset="0"/>
+              </a:rPr>
+              <a:t> FROM </a:t>
             </a:r>
             <a:r>
               <a:rPr lang="pt-BR" sz="1400" dirty="0" err="1">
                 <a:latin typeface="Times New Roman" panose="02020603050405020304" pitchFamily="18" charset="0"/>
                 <a:cs typeface="Times New Roman" panose="02020603050405020304" pitchFamily="18" charset="0"/>
               </a:rPr>
-              <a:t>int</a:t>
-            </a:r>
-            <a:r>
-              <a:rPr lang="pt-BR" sz="1400" dirty="0">
-                <a:latin typeface="Times New Roman" panose="02020603050405020304" pitchFamily="18" charset="0"/>
-                <a:cs typeface="Times New Roman" panose="02020603050405020304" pitchFamily="18" charset="0"/>
-              </a:rPr>
-              <a:t>(input("Digite o ID do departamento para deletar: "))</a:t>
-            </a:r>
-          </a:p>
-          <a:p>
-            <a:pPr marL="0" indent="0" algn="just">
-              <a:buNone/>
-            </a:pPr>
-            <a:r>
-              <a:rPr lang="pt-BR" sz="1400" dirty="0" err="1">
-                <a:latin typeface="Times New Roman" panose="02020603050405020304" pitchFamily="18" charset="0"/>
-                <a:cs typeface="Times New Roman" panose="02020603050405020304" pitchFamily="18" charset="0"/>
-              </a:rPr>
-              <a:t>sql</a:t>
-            </a:r>
-            <a:r>
-              <a:rPr lang="pt-BR" sz="1400" dirty="0">
-                <a:latin typeface="Times New Roman" panose="02020603050405020304" pitchFamily="18" charset="0"/>
-                <a:cs typeface="Times New Roman" panose="02020603050405020304" pitchFamily="18" charset="0"/>
-              </a:rPr>
-              <a:t> = "DELETE FROM </a:t>
-            </a:r>
-            <a:r>
-              <a:rPr lang="pt-BR" sz="1400" dirty="0" err="1">
-                <a:latin typeface="Times New Roman" panose="02020603050405020304" pitchFamily="18" charset="0"/>
-                <a:cs typeface="Times New Roman" panose="02020603050405020304" pitchFamily="18" charset="0"/>
-              </a:rPr>
-              <a:t>departament</a:t>
+              <a:t>department</a:t>
             </a:r>
             <a:r>
               <a:rPr lang="pt-BR" sz="1400" dirty="0">

</xml_diff>